<commit_message>
docs(slides): refresh pitch deck to v0.29 — 14 built-in verbs, show/info discovery
The "What's working today" and roadmap slides now read v0.29 (was v0.27): ~45 alias
verbs + 14 built-ins (was 12), a "Discovery, delivery & quality" card highlighting
show / info / catalog, and 300+ tests (was 270+). Regenerated the PowerPoint (python-pptx),
Marp HTML, and Marp PDF.

Co-Authored-By: Claude Opus 4.8 (1M context) <noreply@anthropic.com>
</commit_message>
<xml_diff>
--- a/docs/presentation/niva_pitch.pptx
+++ b/docs/presentation/niva_pitch.pptx
@@ -7052,7 +7052,7 @@
                 </a:solidFill>
                 <a:latin typeface="Arial"/>
               </a:rPr>
-              <a:t>niva ships as a QGIS plugin (v0.27) and runs real analysis end-to-end, on QGIS's own algorithms:</a:t>
+              <a:t>niva ships as a QGIS plugin (v0.29) and runs real analysis end-to-end, on QGIS's own algorithms:</a:t>
             </a:r>
           </a:p>
         </p:txBody>
@@ -7452,7 +7452,7 @@
                 </a:solidFill>
                 <a:latin typeface="Arial"/>
               </a:rPr>
-              <a:t>~45 alias verbs + 12 built-ins (vector + raster)</a:t>
+              <a:t>~45 alias verbs + 14 built-ins (vector + raster)</a:t>
             </a:r>
           </a:p>
           <a:p>
@@ -7854,7 +7854,7 @@
                 </a:solidFill>
                 <a:latin typeface="Arial"/>
               </a:rPr>
-              <a:t>Delivery &amp; quality</a:t>
+              <a:t>Discovery, delivery &amp; quality</a:t>
             </a:r>
           </a:p>
         </p:txBody>
@@ -7902,6 +7902,31 @@
                 </a:solidFill>
                 <a:latin typeface="Arial"/>
               </a:rPr>
+              <a:t>show / info / catalog — list data, inspect environment</a:t>
+            </a:r>
+          </a:p>
+          <a:p>
+            <a:pPr algn="l">
+              <a:lnSpc>
+                <a:spcPct val="130000"/>
+              </a:lnSpc>
+            </a:pPr>
+            <a:r>
+              <a:rPr sz="1400" b="1" i="0">
+                <a:solidFill>
+                  <a:srgbClr val="465753"/>
+                </a:solidFill>
+                <a:latin typeface="Arial"/>
+              </a:rPr>
+              <a:t>✓  </a:t>
+            </a:r>
+            <a:r>
+              <a:rPr sz="1400" b="0" i="0">
+                <a:solidFill>
+                  <a:srgbClr val="6B7B6F"/>
+                </a:solidFill>
+                <a:latin typeface="Arial"/>
+              </a:rPr>
               <a:t>QGIS plugin (Install from ZIP) · CLI · Python API</a:t>
             </a:r>
           </a:p>
@@ -7927,32 +7952,7 @@
                 </a:solidFill>
                 <a:latin typeface="Arial"/>
               </a:rPr>
-              <a:t>Provenance journal · assess · catalog · notify / email</a:t>
-            </a:r>
-          </a:p>
-          <a:p>
-            <a:pPr algn="l">
-              <a:lnSpc>
-                <a:spcPct val="130000"/>
-              </a:lnSpc>
-            </a:pPr>
-            <a:r>
-              <a:rPr sz="1400" b="1" i="0">
-                <a:solidFill>
-                  <a:srgbClr val="465753"/>
-                </a:solidFill>
-                <a:latin typeface="Arial"/>
-              </a:rPr>
-              <a:t>✓  </a:t>
-            </a:r>
-            <a:r>
-              <a:rPr sz="1400" b="0" i="0">
-                <a:solidFill>
-                  <a:srgbClr val="6B7B6F"/>
-                </a:solidFill>
-                <a:latin typeface="Arial"/>
-              </a:rPr>
-              <a:t>270+ tests, live-QGIS + PostGIS CI · full docs</a:t>
+              <a:t>300+ tests, live-QGIS + PostGIS CI · full docs</a:t>
             </a:r>
           </a:p>
         </p:txBody>
@@ -8358,7 +8358,7 @@
                 </a:solidFill>
                 <a:latin typeface="Arial"/>
               </a:rPr>
-              <a:t>v0.27</a:t>
+              <a:t>v0.29</a:t>
             </a:r>
           </a:p>
         </p:txBody>
@@ -8445,7 +8445,7 @@
                 </a:solidFill>
                 <a:latin typeface="Arial"/>
               </a:rPr>
-              <a:t>~45 verbs + raster · run → 769 · PostGIS read·write·analyse · project / template / style · QGIS plugin · CLI / Python · full docs</a:t>
+              <a:t>~45 verbs + raster · run → 769 · PostGIS read·write·analyse · project / template / style · show / info discovery · QGIS plugin · CLI / Python · full docs</a:t>
             </a:r>
           </a:p>
         </p:txBody>

</xml_diff>

<commit_message>
docs: rebuild guide PDF + pitch deck for 0.62 (point clouds, all-types, hydrology, multispectral)
Guide PDF regenerated from the refreshed guides + algorithm appendices. Pitch deck: 3 new
capability slides (every data type / point cloud → watershed / terrain+imagery+features fusion),
and the stale 'working today' + roadmap + 769→878 stats brought current (v0.62, on PyPI, 48 verbs,
660+ tests). Both Marp (HTML+PDF) and PPTX rebuilt.
</commit_message>
<xml_diff>
--- a/docs/presentation/niva_pitch.pptx
+++ b/docs/presentation/niva_pitch.pptx
@@ -4472,7 +4472,7 @@
                 </a:solidFill>
                 <a:latin typeface="Arial"/>
               </a:rPr>
-              <a:t>769</a:t>
+              <a:t>878</a:t>
             </a:r>
           </a:p>
         </p:txBody>
@@ -7052,7 +7052,7 @@
                 </a:solidFill>
                 <a:latin typeface="Arial"/>
               </a:rPr>
-              <a:t>niva ships as a QGIS plugin (v0.31) and runs real analysis end-to-end, on QGIS's own algorithms:</a:t>
+              <a:t>niva ships as a QGIS plugin (v0.62) and on PyPI, and runs real analysis end-to-end on QGIS's own algorithms:</a:t>
             </a:r>
           </a:p>
         </p:txBody>
@@ -7452,7 +7452,7 @@
                 </a:solidFill>
                 <a:latin typeface="Arial"/>
               </a:rPr>
-              <a:t>~45 alias verbs + 14 built-ins (vector + raster)</a:t>
+              <a:t>48 alias verbs + built-ins (vector · raster · point cloud)</a:t>
             </a:r>
           </a:p>
           <a:p>
@@ -7502,7 +7502,7 @@
                 </a:solidFill>
                 <a:latin typeface="Arial"/>
               </a:rPr>
-              <a:t>run — reach ANY of QGIS's 769 algorithms</a:t>
+              <a:t>run — reach ANY of QGIS's 878 algorithms</a:t>
             </a:r>
           </a:p>
         </p:txBody>
@@ -7629,7 +7629,7 @@
                 </a:solidFill>
                 <a:latin typeface="Arial"/>
               </a:rPr>
-              <a:t>Data &amp; cartography</a:t>
+              <a:t>Every data type</a:t>
             </a:r>
           </a:p>
         </p:txBody>
@@ -7677,7 +7677,7 @@
                 </a:solidFill>
                 <a:latin typeface="Arial"/>
               </a:rPr>
-              <a:t>PostGIS &amp; SpatiaLite — read · write · analyse</a:t>
+              <a:t>Vector · raster · point cloud · mesh discovery</a:t>
             </a:r>
           </a:p>
           <a:p>
@@ -7702,7 +7702,7 @@
                 </a:solidFill>
                 <a:latin typeface="Arial"/>
               </a:rPr>
-              <a:t>project — repoint / build / templates · bookmarks</a:t>
+              <a:t>LiDAR: dtm / dsm / hag · GRASS + SAGA hydrology</a:t>
             </a:r>
           </a:p>
           <a:p>
@@ -7727,7 +7727,7 @@
                 </a:solidFill>
                 <a:latin typeface="Arial"/>
               </a:rPr>
-              <a:t>style — apply / export .qml · .sld · .qlr</a:t>
+              <a:t>Landsat / Sentinel-2 / NAIP fusion → NDVI</a:t>
             </a:r>
           </a:p>
         </p:txBody>
@@ -7854,7 +7854,7 @@
                 </a:solidFill>
                 <a:latin typeface="Arial"/>
               </a:rPr>
-              <a:t>Discovery, delivery &amp; quality</a:t>
+              <a:t>Data, cartography &amp; delivery</a:t>
             </a:r>
           </a:p>
         </p:txBody>
@@ -7902,7 +7902,7 @@
                 </a:solidFill>
                 <a:latin typeface="Arial"/>
               </a:rPr>
-              <a:t>show / info / catalog — list data, inspect environment</a:t>
+              <a:t>PostGIS &amp; SpatiaLite — read · write · analyse</a:t>
             </a:r>
           </a:p>
           <a:p>
@@ -7927,7 +7927,7 @@
                 </a:solidFill>
                 <a:latin typeface="Arial"/>
               </a:rPr>
-              <a:t>QGIS plugin (Install from ZIP) · CLI · Python API</a:t>
+              <a:t>project / style · figure / map · show / catalog</a:t>
             </a:r>
           </a:p>
           <a:p>
@@ -7952,7 +7952,7 @@
                 </a:solidFill>
                 <a:latin typeface="Arial"/>
               </a:rPr>
-              <a:t>300+ tests, live-QGIS + PostGIS CI · full docs</a:t>
+              <a:t>Plugin · CLI · Python · LSP · 660+ tests · full docs</a:t>
             </a:r>
           </a:p>
         </p:txBody>
@@ -8358,7 +8358,7 @@
                 </a:solidFill>
                 <a:latin typeface="Arial"/>
               </a:rPr>
-              <a:t>v0.31</a:t>
+              <a:t>v0.62</a:t>
             </a:r>
           </a:p>
         </p:txBody>
@@ -8397,7 +8397,7 @@
                 </a:solidFill>
                 <a:latin typeface="Arial"/>
               </a:rPr>
-              <a:t>Shipped — available now</a:t>
+              <a:t>Shipped — available now, on PyPI</a:t>
             </a:r>
             <a:r>
               <a:rPr sz="1300" b="1" i="1">
@@ -8445,7 +8445,7 @@
                 </a:solidFill>
                 <a:latin typeface="Arial"/>
               </a:rPr>
-              <a:t>~45 verbs + raster · run → 769 · PostGIS read·write·analyse · project / template / style · show / info discovery · QGIS plugin · CLI / Python · full docs</a:t>
+              <a:t>48 verbs + raster · run → 878 · point clouds + mesh + all-types discovery · GRASS/SAGA hydrology · multispectral fusion · PostGIS read·write·analyse · project / style · figure / map · LSP · plugin · CLI / Python · full docs</a:t>
             </a:r>
           </a:p>
         </p:txBody>
@@ -8606,7 +8606,7 @@
                 </a:solidFill>
                 <a:latin typeface="Arial"/>
               </a:rPr>
-              <a:t>Grammar freeze (SemVer) · PyPI publish · worked Marimo–QGIS integration</a:t>
+              <a:t>Grammar freeze (SemVer) · worked Marimo–QGIS integration</a:t>
             </a:r>
           </a:p>
         </p:txBody>

</xml_diff>